<commit_message>
Praesentation: Sensor-Drift (ThingSpeak/MATLAB) als realisiert nachgezogen, MATLAB-Skript ins Repo
Co-Authored-By: Claude Sonnet 5.5 <noreply@anthropic.com>
Claude-Session: https://claude.ai/code/session_01DAyhZuQPfkaakwWeF4BFCC
</commit_message>
<xml_diff>
--- a/Praesentation/ice-truck-praesentation.pptx
+++ b/Praesentation/ice-truck-praesentation.pptx
@@ -15168,7 +15168,7 @@
                 </a:solidFill>
                 <a:latin typeface="Calibri"/>
               </a:rPr>
-              <a:t>Ausblick:</a:t>
+              <a:t>Challenge III (Cloud) – Sensor-Drift realisiert:</a:t>
             </a:r>
             <a:r>
               <a:rPr sz="1500">
@@ -15177,7 +15177,7 @@
                 </a:solidFill>
                 <a:latin typeface="Calibri"/>
               </a:rPr>
-              <a:t> Challenge III (Cloud-Speicherung/-Auswertung) – noch nicht begonnen</a:t>
+              <a:t> ThingSpeak-Kanal mit MATLAB-Visualisierung (1-min-Mittel der Abweichung beider Sensoren, Warnschwelle 3 °C) zeigt, ob die beiden KY-028 auseinanderlaufen – Predictive Maintenance. Azure-IoT-Hub-Anbindung vorbereitet, Ende-zu-Ende-Test steht noch aus</a:t>
             </a:r>
           </a:p>
         </p:txBody>

</xml_diff>